<commit_message>
Rewrite the Level 4 lines the checker could not hear
Lesson 1 says "we have" where Whisper dropped "we've." Lesson 2 says Parkview, four eighteen Elm Street, and a full start-date question. Lesson 3 says "those shelves are done" and "we have already." Lesson 4 says the blood pressure looks normal. Each lesson's grammar stays.
</commit_message>
<xml_diff>
--- a/level4/slides/Level4_Lesson2_Slides.pptx
+++ b/level4/slides/Level4_Lesson2_Slides.pptx
@@ -1516,7 +1516,7 @@
           </a:p>
           <a:p>
             <a:r>
-              <a:t>Mr. Chen: Good afternoon. Welcome to Park View Apartments. How can I help you?</a:t>
+              <a:t>Mr. Chen: Good afternoon. Welcome to Parkview Apartments. How can I help you?</a:t>
             </a:r>
           </a:p>
           <a:p>
@@ -1531,7 +1531,7 @@
           </a:p>
           <a:p>
             <a:r>
-              <a:t>Marisol: It's 418 Elm Street, apartment 3.</a:t>
+              <a:t>Marisol: It's four eighteen Elm Street, apartment 3.</a:t>
             </a:r>
           </a:p>
           <a:p>
@@ -1586,7 +1586,7 @@
           </a:p>
           <a:p>
             <a:r>
-              <a:t>Mr. Chen: And your start date at the clinic? March what?</a:t>
+              <a:t>Mr. Chen: And what day in March did you start at the clinic?</a:t>
             </a:r>
           </a:p>
           <a:p>
@@ -2171,7 +2171,7 @@
           </a:p>
           <a:p>
             <a:r>
-              <a:t>Read the three lines under "Today you will". Give one quick example of each: "How long have you lived here?" • "I've lived here for two years. / since 2024." • "Current address: 418 Elm Street."</a:t>
+              <a:t>Read the three lines under "Today you will". Give one quick example of each: "How long have you lived here?" • "I've lived here for two years. / since 2024." • "Current address: four eighteen Elm Street."</a:t>
             </a:r>
           </a:p>
           <a:p>
@@ -13539,7 +13539,7 @@
                 <a:ea typeface="Lexend Deca" pitchFamily="34" charset="-122"/>
                 <a:cs typeface="Lexend Deca" pitchFamily="34" charset="-120"/>
               </a:rPr>
-              <a:t>Park View</a:t>
+              <a:t>Parkview</a:t>
             </a:r>
             <a:endParaRPr lang="en-US" sz="1400" dirty="0" b="1"/>
           </a:p>
@@ -13768,7 +13768,7 @@
                 <a:ea typeface="Lexend Deca" pitchFamily="34" charset="-122"/>
                 <a:cs typeface="Lexend Deca" pitchFamily="34" charset="-120"/>
               </a:rPr>
-              <a:t>Park View Apartments</a:t>
+              <a:t>Parkview Apartments</a:t>
             </a:r>
             <a:endParaRPr lang="en-US" sz="1400" dirty="0" b="1"/>
           </a:p>
@@ -29167,7 +29167,7 @@
                 <a:ea typeface="Lexend Deca" pitchFamily="34" charset="-122"/>
                 <a:cs typeface="Lexend Deca" pitchFamily="34" charset="-120"/>
               </a:rPr>
-              <a:t>Park View Apartments:</a:t>
+              <a:t>Parkview Apartments:</a:t>
             </a:r>
             <a:endParaRPr lang="en-US" sz="2000" dirty="0" b="1"/>
           </a:p>

</xml_diff>